<commit_message>
feat: make individual figure PPTXs fully editable (native shapes/tables)
Replaced embedded PNG images with native PowerPoint elements:
- Figure 1: Rounded rectangles + text boxes (PRISMA flowchart)
- Figure 2: Shaped boxes with text (conceptual framework) - fixed bottom cutoff
- Figure 3: PowerPoint table with colored cells (risk matrix)
- Figure 4: Timeline with positioned boxes (guideline timeline)
- Figure 5: Table with color-coded severity scores (gap severity)

Co-Authored-By: Tatsuki Onishi <bougtoir@gmail.com>
</commit_message>
<xml_diff>
--- a/wada-tue-scoping-review/manuscripts/individual_figures/Figure_1.pptx
+++ b/wada-tue-scoping-review/manuscripts/individual_figures/Figure_1.pptx
@@ -3112,46 +3112,688 @@
           <a:p>
             <a:pPr algn="ctr"/>
             <a:r>
-              <a:rPr b="1" sz="2400"/>
-              <a:t>Figure 1</a:t>
-            </a:r>
-          </a:p>
-        </p:txBody>
-      </p:sp>
-      <p:pic>
-        <p:nvPicPr>
-          <p:cNvPr id="3" name="Picture 2" descr="fig1_prisma_flowchart.png"/>
-          <p:cNvPicPr>
-            <a:picLocks noChangeAspect="1"/>
-          </p:cNvPicPr>
+              <a:rPr b="1" sz="2000">
+                <a:solidFill>
+                  <a:srgbClr val="1B3A5C"/>
+                </a:solidFill>
+              </a:rPr>
+              <a:t>Figure 1. PRISMA-ScR Flow Diagram</a:t>
+            </a:r>
+          </a:p>
+        </p:txBody>
+      </p:sp>
+      <p:sp>
+        <p:nvSpPr>
+          <p:cNvPr id="3" name="Rounded Rectangle 2"/>
+          <p:cNvSpPr/>
           <p:nvPr/>
-        </p:nvPicPr>
-        <p:blipFill>
-          <a:blip r:embed="rId2"/>
-          <a:stretch>
-            <a:fillRect/>
-          </a:stretch>
-        </p:blipFill>
+        </p:nvSpPr>
         <p:spPr>
           <a:xfrm>
-            <a:off x="4194049" y="914400"/>
-            <a:ext cx="3803596" cy="4572000"/>
+            <a:off x="2286000" y="914400"/>
+            <a:ext cx="2743200" cy="640080"/>
           </a:xfrm>
-          <a:prstGeom prst="rect">
+          <a:prstGeom prst="roundRect">
             <a:avLst/>
           </a:prstGeom>
+          <a:solidFill>
+            <a:srgbClr val="BBDEFB"/>
+          </a:solidFill>
+          <a:ln w="19050">
+            <a:solidFill>
+              <a:srgbClr val="1B3A5C"/>
+            </a:solidFill>
+          </a:ln>
         </p:spPr>
-      </p:pic>
-      <p:sp>
-        <p:nvSpPr>
-          <p:cNvPr id="4" name="TextBox 3"/>
+        <p:style>
+          <a:lnRef idx="1">
+            <a:schemeClr val="accent1"/>
+          </a:lnRef>
+          <a:fillRef idx="3">
+            <a:schemeClr val="accent1"/>
+          </a:fillRef>
+          <a:effectRef idx="2">
+            <a:schemeClr val="accent1"/>
+          </a:effectRef>
+          <a:fontRef idx="minor">
+            <a:schemeClr val="lt1"/>
+          </a:fontRef>
+        </p:style>
+        <p:txBody>
+          <a:bodyPr rtlCol="0" anchor="ctr" wrap="square" tIns="50800" bIns="50800"/>
+          <a:lstStyle/>
+          <a:p>
+            <a:pPr algn="ctr">
+              <a:spcBef>
+                <a:spcPts val="0"/>
+              </a:spcBef>
+              <a:spcAft>
+                <a:spcPts val="0"/>
+              </a:spcAft>
+            </a:pPr>
+            <a:r>
+              <a:rPr sz="900" b="0">
+                <a:solidFill>
+                  <a:srgbClr val="424242"/>
+                </a:solidFill>
+              </a:rPr>
+              <a:t>Records from database searching
+(n = 847)</a:t>
+            </a:r>
+          </a:p>
+        </p:txBody>
+      </p:sp>
+      <p:sp>
+        <p:nvSpPr>
+          <p:cNvPr id="4" name="Rounded Rectangle 3"/>
+          <p:cNvSpPr/>
+          <p:nvPr/>
+        </p:nvSpPr>
+        <p:spPr>
+          <a:xfrm>
+            <a:off x="6858000" y="914400"/>
+            <a:ext cx="2743200" cy="640080"/>
+          </a:xfrm>
+          <a:prstGeom prst="roundRect">
+            <a:avLst/>
+          </a:prstGeom>
+          <a:solidFill>
+            <a:srgbClr val="BBDEFB"/>
+          </a:solidFill>
+          <a:ln w="19050">
+            <a:solidFill>
+              <a:srgbClr val="1B3A5C"/>
+            </a:solidFill>
+          </a:ln>
+        </p:spPr>
+        <p:style>
+          <a:lnRef idx="1">
+            <a:schemeClr val="accent1"/>
+          </a:lnRef>
+          <a:fillRef idx="3">
+            <a:schemeClr val="accent1"/>
+          </a:fillRef>
+          <a:effectRef idx="2">
+            <a:schemeClr val="accent1"/>
+          </a:effectRef>
+          <a:fontRef idx="minor">
+            <a:schemeClr val="lt1"/>
+          </a:fontRef>
+        </p:style>
+        <p:txBody>
+          <a:bodyPr rtlCol="0" anchor="ctr" wrap="square" tIns="50800" bIns="50800"/>
+          <a:lstStyle/>
+          <a:p>
+            <a:pPr algn="ctr">
+              <a:spcBef>
+                <a:spcPts val="0"/>
+              </a:spcBef>
+              <a:spcAft>
+                <a:spcPts val="0"/>
+              </a:spcAft>
+            </a:pPr>
+            <a:r>
+              <a:rPr sz="900" b="0">
+                <a:solidFill>
+                  <a:srgbClr val="424242"/>
+                </a:solidFill>
+              </a:rPr>
+              <a:t>Additional records from
+grey literature &amp; guidelines (n = 156)</a:t>
+            </a:r>
+          </a:p>
+        </p:txBody>
+      </p:sp>
+      <p:sp>
+        <p:nvSpPr>
+          <p:cNvPr id="5" name="Rounded Rectangle 4"/>
+          <p:cNvSpPr/>
+          <p:nvPr/>
+        </p:nvSpPr>
+        <p:spPr>
+          <a:xfrm>
+            <a:off x="3840480" y="1828800"/>
+            <a:ext cx="4114800" cy="640080"/>
+          </a:xfrm>
+          <a:prstGeom prst="roundRect">
+            <a:avLst/>
+          </a:prstGeom>
+          <a:solidFill>
+            <a:srgbClr val="C8E6C9"/>
+          </a:solidFill>
+          <a:ln w="19050">
+            <a:solidFill>
+              <a:srgbClr val="2E7D32"/>
+            </a:solidFill>
+          </a:ln>
+        </p:spPr>
+        <p:style>
+          <a:lnRef idx="1">
+            <a:schemeClr val="accent1"/>
+          </a:lnRef>
+          <a:fillRef idx="3">
+            <a:schemeClr val="accent1"/>
+          </a:fillRef>
+          <a:effectRef idx="2">
+            <a:schemeClr val="accent1"/>
+          </a:effectRef>
+          <a:fontRef idx="minor">
+            <a:schemeClr val="lt1"/>
+          </a:fontRef>
+        </p:style>
+        <p:txBody>
+          <a:bodyPr rtlCol="0" anchor="ctr" wrap="square" tIns="50800" bIns="50800"/>
+          <a:lstStyle/>
+          <a:p>
+            <a:pPr algn="ctr">
+              <a:spcBef>
+                <a:spcPts val="0"/>
+              </a:spcBef>
+              <a:spcAft>
+                <a:spcPts val="0"/>
+              </a:spcAft>
+            </a:pPr>
+            <a:r>
+              <a:rPr sz="1000" b="0">
+                <a:solidFill>
+                  <a:srgbClr val="424242"/>
+                </a:solidFill>
+              </a:rPr>
+              <a:t>Records after duplicates removed (n = 724)</a:t>
+            </a:r>
+          </a:p>
+        </p:txBody>
+      </p:sp>
+      <p:sp>
+        <p:nvSpPr>
+          <p:cNvPr id="6" name="Rounded Rectangle 5"/>
+          <p:cNvSpPr/>
+          <p:nvPr/>
+        </p:nvSpPr>
+        <p:spPr>
+          <a:xfrm>
+            <a:off x="3840480" y="2743200"/>
+            <a:ext cx="4114800" cy="640080"/>
+          </a:xfrm>
+          <a:prstGeom prst="roundRect">
+            <a:avLst/>
+          </a:prstGeom>
+          <a:solidFill>
+            <a:srgbClr val="C8E6C9"/>
+          </a:solidFill>
+          <a:ln w="19050">
+            <a:solidFill>
+              <a:srgbClr val="2E7D32"/>
+            </a:solidFill>
+          </a:ln>
+        </p:spPr>
+        <p:style>
+          <a:lnRef idx="1">
+            <a:schemeClr val="accent1"/>
+          </a:lnRef>
+          <a:fillRef idx="3">
+            <a:schemeClr val="accent1"/>
+          </a:fillRef>
+          <a:effectRef idx="2">
+            <a:schemeClr val="accent1"/>
+          </a:effectRef>
+          <a:fontRef idx="minor">
+            <a:schemeClr val="lt1"/>
+          </a:fontRef>
+        </p:style>
+        <p:txBody>
+          <a:bodyPr rtlCol="0" anchor="ctr" wrap="square" tIns="50800" bIns="50800"/>
+          <a:lstStyle/>
+          <a:p>
+            <a:pPr algn="ctr">
+              <a:spcBef>
+                <a:spcPts val="0"/>
+              </a:spcBef>
+              <a:spcAft>
+                <a:spcPts val="0"/>
+              </a:spcAft>
+            </a:pPr>
+            <a:r>
+              <a:rPr sz="1000" b="0">
+                <a:solidFill>
+                  <a:srgbClr val="424242"/>
+                </a:solidFill>
+              </a:rPr>
+              <a:t>Records screened by title/abstract (n = 724)</a:t>
+            </a:r>
+          </a:p>
+        </p:txBody>
+      </p:sp>
+      <p:sp>
+        <p:nvSpPr>
+          <p:cNvPr id="7" name="Rounded Rectangle 6"/>
+          <p:cNvSpPr/>
+          <p:nvPr/>
+        </p:nvSpPr>
+        <p:spPr>
+          <a:xfrm>
+            <a:off x="8686800" y="2743200"/>
+            <a:ext cx="2286000" cy="640080"/>
+          </a:xfrm>
+          <a:prstGeom prst="roundRect">
+            <a:avLst/>
+          </a:prstGeom>
+          <a:solidFill>
+            <a:srgbClr val="FFCDD2"/>
+          </a:solidFill>
+          <a:ln w="19050">
+            <a:solidFill>
+              <a:srgbClr val="C62828"/>
+            </a:solidFill>
+          </a:ln>
+        </p:spPr>
+        <p:style>
+          <a:lnRef idx="1">
+            <a:schemeClr val="accent1"/>
+          </a:lnRef>
+          <a:fillRef idx="3">
+            <a:schemeClr val="accent1"/>
+          </a:fillRef>
+          <a:effectRef idx="2">
+            <a:schemeClr val="accent1"/>
+          </a:effectRef>
+          <a:fontRef idx="minor">
+            <a:schemeClr val="lt1"/>
+          </a:fontRef>
+        </p:style>
+        <p:txBody>
+          <a:bodyPr rtlCol="0" anchor="ctr" wrap="square" tIns="50800" bIns="50800"/>
+          <a:lstStyle/>
+          <a:p>
+            <a:pPr algn="ctr">
+              <a:spcBef>
+                <a:spcPts val="0"/>
+              </a:spcBef>
+              <a:spcAft>
+                <a:spcPts val="0"/>
+              </a:spcAft>
+            </a:pPr>
+            <a:r>
+              <a:rPr sz="900" b="0">
+                <a:solidFill>
+                  <a:srgbClr val="424242"/>
+                </a:solidFill>
+              </a:rPr>
+              <a:t>Records excluded (n = 518)</a:t>
+            </a:r>
+          </a:p>
+        </p:txBody>
+      </p:sp>
+      <p:sp>
+        <p:nvSpPr>
+          <p:cNvPr id="8" name="Rounded Rectangle 7"/>
+          <p:cNvSpPr/>
+          <p:nvPr/>
+        </p:nvSpPr>
+        <p:spPr>
+          <a:xfrm>
+            <a:off x="3840480" y="3657600"/>
+            <a:ext cx="4114800" cy="640080"/>
+          </a:xfrm>
+          <a:prstGeom prst="roundRect">
+            <a:avLst/>
+          </a:prstGeom>
+          <a:solidFill>
+            <a:srgbClr val="FFF9C4"/>
+          </a:solidFill>
+          <a:ln w="19050">
+            <a:solidFill>
+              <a:srgbClr val="F9A825"/>
+            </a:solidFill>
+          </a:ln>
+        </p:spPr>
+        <p:style>
+          <a:lnRef idx="1">
+            <a:schemeClr val="accent1"/>
+          </a:lnRef>
+          <a:fillRef idx="3">
+            <a:schemeClr val="accent1"/>
+          </a:fillRef>
+          <a:effectRef idx="2">
+            <a:schemeClr val="accent1"/>
+          </a:effectRef>
+          <a:fontRef idx="minor">
+            <a:schemeClr val="lt1"/>
+          </a:fontRef>
+        </p:style>
+        <p:txBody>
+          <a:bodyPr rtlCol="0" anchor="ctr" wrap="square" tIns="50800" bIns="50800"/>
+          <a:lstStyle/>
+          <a:p>
+            <a:pPr algn="ctr">
+              <a:spcBef>
+                <a:spcPts val="0"/>
+              </a:spcBef>
+              <a:spcAft>
+                <a:spcPts val="0"/>
+              </a:spcAft>
+            </a:pPr>
+            <a:r>
+              <a:rPr sz="1000" b="0">
+                <a:solidFill>
+                  <a:srgbClr val="424242"/>
+                </a:solidFill>
+              </a:rPr>
+              <a:t>Full-text assessed for eligibility (n = 206)</a:t>
+            </a:r>
+          </a:p>
+        </p:txBody>
+      </p:sp>
+      <p:sp>
+        <p:nvSpPr>
+          <p:cNvPr id="9" name="Rounded Rectangle 8"/>
+          <p:cNvSpPr/>
+          <p:nvPr/>
+        </p:nvSpPr>
+        <p:spPr>
+          <a:xfrm>
+            <a:off x="8686800" y="3657600"/>
+            <a:ext cx="2286000" cy="640080"/>
+          </a:xfrm>
+          <a:prstGeom prst="roundRect">
+            <a:avLst/>
+          </a:prstGeom>
+          <a:solidFill>
+            <a:srgbClr val="FFCDD2"/>
+          </a:solidFill>
+          <a:ln w="19050">
+            <a:solidFill>
+              <a:srgbClr val="C62828"/>
+            </a:solidFill>
+          </a:ln>
+        </p:spPr>
+        <p:style>
+          <a:lnRef idx="1">
+            <a:schemeClr val="accent1"/>
+          </a:lnRef>
+          <a:fillRef idx="3">
+            <a:schemeClr val="accent1"/>
+          </a:fillRef>
+          <a:effectRef idx="2">
+            <a:schemeClr val="accent1"/>
+          </a:effectRef>
+          <a:fontRef idx="minor">
+            <a:schemeClr val="lt1"/>
+          </a:fontRef>
+        </p:style>
+        <p:txBody>
+          <a:bodyPr rtlCol="0" anchor="ctr" wrap="square" tIns="50800" bIns="50800"/>
+          <a:lstStyle/>
+          <a:p>
+            <a:pPr algn="ctr">
+              <a:spcBef>
+                <a:spcPts val="0"/>
+              </a:spcBef>
+              <a:spcAft>
+                <a:spcPts val="0"/>
+              </a:spcAft>
+            </a:pPr>
+            <a:r>
+              <a:rPr sz="900" b="0">
+                <a:solidFill>
+                  <a:srgbClr val="424242"/>
+                </a:solidFill>
+              </a:rPr>
+              <a:t>Full-text excluded (n = 138)</a:t>
+            </a:r>
+          </a:p>
+        </p:txBody>
+      </p:sp>
+      <p:sp>
+        <p:nvSpPr>
+          <p:cNvPr id="10" name="Rounded Rectangle 9"/>
+          <p:cNvSpPr/>
+          <p:nvPr/>
+        </p:nvSpPr>
+        <p:spPr>
+          <a:xfrm>
+            <a:off x="3840480" y="4572000"/>
+            <a:ext cx="4114800" cy="640080"/>
+          </a:xfrm>
+          <a:prstGeom prst="roundRect">
+            <a:avLst/>
+          </a:prstGeom>
+          <a:solidFill>
+            <a:srgbClr val="C8E6C9"/>
+          </a:solidFill>
+          <a:ln w="19050">
+            <a:solidFill>
+              <a:srgbClr val="2E7D32"/>
+            </a:solidFill>
+          </a:ln>
+        </p:spPr>
+        <p:style>
+          <a:lnRef idx="1">
+            <a:schemeClr val="accent1"/>
+          </a:lnRef>
+          <a:fillRef idx="3">
+            <a:schemeClr val="accent1"/>
+          </a:fillRef>
+          <a:effectRef idx="2">
+            <a:schemeClr val="accent1"/>
+          </a:effectRef>
+          <a:fontRef idx="minor">
+            <a:schemeClr val="lt1"/>
+          </a:fontRef>
+        </p:style>
+        <p:txBody>
+          <a:bodyPr rtlCol="0" anchor="ctr" wrap="square" tIns="50800" bIns="50800"/>
+          <a:lstStyle/>
+          <a:p>
+            <a:pPr algn="ctr">
+              <a:spcBef>
+                <a:spcPts val="0"/>
+              </a:spcBef>
+              <a:spcAft>
+                <a:spcPts val="0"/>
+              </a:spcAft>
+            </a:pPr>
+            <a:r>
+              <a:rPr sz="1100" b="1">
+                <a:solidFill>
+                  <a:srgbClr val="424242"/>
+                </a:solidFill>
+              </a:rPr>
+              <a:t>Sources included in review (n = 68)</a:t>
+            </a:r>
+          </a:p>
+        </p:txBody>
+      </p:sp>
+      <p:sp>
+        <p:nvSpPr>
+          <p:cNvPr id="11" name="Rounded Rectangle 10"/>
+          <p:cNvSpPr/>
+          <p:nvPr/>
+        </p:nvSpPr>
+        <p:spPr>
+          <a:xfrm>
+            <a:off x="1828800" y="5486400"/>
+            <a:ext cx="2560320" cy="548640"/>
+          </a:xfrm>
+          <a:prstGeom prst="roundRect">
+            <a:avLst/>
+          </a:prstGeom>
+          <a:solidFill>
+            <a:srgbClr val="E3F2FD"/>
+          </a:solidFill>
+          <a:ln w="19050">
+            <a:solidFill>
+              <a:srgbClr val="1565C0"/>
+            </a:solidFill>
+          </a:ln>
+        </p:spPr>
+        <p:style>
+          <a:lnRef idx="1">
+            <a:schemeClr val="accent1"/>
+          </a:lnRef>
+          <a:fillRef idx="3">
+            <a:schemeClr val="accent1"/>
+          </a:fillRef>
+          <a:effectRef idx="2">
+            <a:schemeClr val="accent1"/>
+          </a:effectRef>
+          <a:fontRef idx="minor">
+            <a:schemeClr val="lt1"/>
+          </a:fontRef>
+        </p:style>
+        <p:txBody>
+          <a:bodyPr rtlCol="0" anchor="ctr" wrap="square" tIns="50800" bIns="50800"/>
+          <a:lstStyle/>
+          <a:p>
+            <a:pPr algn="ctr">
+              <a:spcBef>
+                <a:spcPts val="0"/>
+              </a:spcBef>
+              <a:spcAft>
+                <a:spcPts val="0"/>
+              </a:spcAft>
+            </a:pPr>
+            <a:r>
+              <a:rPr sz="900" b="0">
+                <a:solidFill>
+                  <a:srgbClr val="424242"/>
+                </a:solidFill>
+              </a:rPr>
+              <a:t>WADA regulatory docs (n = 18)</a:t>
+            </a:r>
+          </a:p>
+        </p:txBody>
+      </p:sp>
+      <p:sp>
+        <p:nvSpPr>
+          <p:cNvPr id="12" name="Rounded Rectangle 11"/>
+          <p:cNvSpPr/>
+          <p:nvPr/>
+        </p:nvSpPr>
+        <p:spPr>
+          <a:xfrm>
+            <a:off x="4754880" y="5486400"/>
+            <a:ext cx="2560320" cy="548640"/>
+          </a:xfrm>
+          <a:prstGeom prst="roundRect">
+            <a:avLst/>
+          </a:prstGeom>
+          <a:solidFill>
+            <a:srgbClr val="E8F5E9"/>
+          </a:solidFill>
+          <a:ln w="19050">
+            <a:solidFill>
+              <a:srgbClr val="2E7D32"/>
+            </a:solidFill>
+          </a:ln>
+        </p:spPr>
+        <p:style>
+          <a:lnRef idx="1">
+            <a:schemeClr val="accent1"/>
+          </a:lnRef>
+          <a:fillRef idx="3">
+            <a:schemeClr val="accent1"/>
+          </a:fillRef>
+          <a:effectRef idx="2">
+            <a:schemeClr val="accent1"/>
+          </a:effectRef>
+          <a:fontRef idx="minor">
+            <a:schemeClr val="lt1"/>
+          </a:fontRef>
+        </p:style>
+        <p:txBody>
+          <a:bodyPr rtlCol="0" anchor="ctr" wrap="square" tIns="50800" bIns="50800"/>
+          <a:lstStyle/>
+          <a:p>
+            <a:pPr algn="ctr">
+              <a:spcBef>
+                <a:spcPts val="0"/>
+              </a:spcBef>
+              <a:spcAft>
+                <a:spcPts val="0"/>
+              </a:spcAft>
+            </a:pPr>
+            <a:r>
+              <a:rPr sz="900" b="0">
+                <a:solidFill>
+                  <a:srgbClr val="424242"/>
+                </a:solidFill>
+              </a:rPr>
+              <a:t>Clinical practice guidelines (n = 22)</a:t>
+            </a:r>
+          </a:p>
+        </p:txBody>
+      </p:sp>
+      <p:sp>
+        <p:nvSpPr>
+          <p:cNvPr id="13" name="Rounded Rectangle 12"/>
+          <p:cNvSpPr/>
+          <p:nvPr/>
+        </p:nvSpPr>
+        <p:spPr>
+          <a:xfrm>
+            <a:off x="7680960" y="5486400"/>
+            <a:ext cx="2560320" cy="548640"/>
+          </a:xfrm>
+          <a:prstGeom prst="roundRect">
+            <a:avLst/>
+          </a:prstGeom>
+          <a:solidFill>
+            <a:srgbClr val="FFF3E0"/>
+          </a:solidFill>
+          <a:ln w="19050">
+            <a:solidFill>
+              <a:srgbClr val="E65100"/>
+            </a:solidFill>
+          </a:ln>
+        </p:spPr>
+        <p:style>
+          <a:lnRef idx="1">
+            <a:schemeClr val="accent1"/>
+          </a:lnRef>
+          <a:fillRef idx="3">
+            <a:schemeClr val="accent1"/>
+          </a:fillRef>
+          <a:effectRef idx="2">
+            <a:schemeClr val="accent1"/>
+          </a:effectRef>
+          <a:fontRef idx="minor">
+            <a:schemeClr val="lt1"/>
+          </a:fontRef>
+        </p:style>
+        <p:txBody>
+          <a:bodyPr rtlCol="0" anchor="ctr" wrap="square" tIns="50800" bIns="50800"/>
+          <a:lstStyle/>
+          <a:p>
+            <a:pPr algn="ctr">
+              <a:spcBef>
+                <a:spcPts val="0"/>
+              </a:spcBef>
+              <a:spcAft>
+                <a:spcPts val="0"/>
+              </a:spcAft>
+            </a:pPr>
+            <a:r>
+              <a:rPr sz="900" b="0">
+                <a:solidFill>
+                  <a:srgbClr val="424242"/>
+                </a:solidFill>
+              </a:rPr>
+              <a:t>Peer-reviewed articles (n = 28)</a:t>
+            </a:r>
+          </a:p>
+        </p:txBody>
+      </p:sp>
+      <p:sp>
+        <p:nvSpPr>
+          <p:cNvPr id="14" name="TextBox 13"/>
           <p:cNvSpPr txBox="1"/>
           <p:nvPr/>
         </p:nvSpPr>
         <p:spPr>
           <a:xfrm>
-            <a:off x="457200" y="5943600"/>
-            <a:ext cx="11247120" cy="731520"/>
+            <a:off x="274320" y="914400"/>
+            <a:ext cx="1645920" cy="457200"/>
           </a:xfrm>
           <a:prstGeom prst="rect">
             <a:avLst/>
@@ -3159,6 +3801,138 @@
           <a:noFill/>
         </p:spPr>
         <p:txBody>
+          <a:bodyPr wrap="none">
+            <a:spAutoFit/>
+          </a:bodyPr>
+          <a:lstStyle/>
+          <a:p>
+            <a:r>
+              <a:rPr sz="800" b="1" i="1">
+                <a:solidFill>
+                  <a:srgbClr val="1B3A5C"/>
+                </a:solidFill>
+              </a:rPr>
+              <a:t>IDENTIFICATION</a:t>
+            </a:r>
+          </a:p>
+        </p:txBody>
+      </p:sp>
+      <p:sp>
+        <p:nvSpPr>
+          <p:cNvPr id="15" name="TextBox 14"/>
+          <p:cNvSpPr txBox="1"/>
+          <p:nvPr/>
+        </p:nvSpPr>
+        <p:spPr>
+          <a:xfrm>
+            <a:off x="274320" y="2743200"/>
+            <a:ext cx="1645920" cy="457200"/>
+          </a:xfrm>
+          <a:prstGeom prst="rect">
+            <a:avLst/>
+          </a:prstGeom>
+          <a:noFill/>
+        </p:spPr>
+        <p:txBody>
+          <a:bodyPr wrap="none">
+            <a:spAutoFit/>
+          </a:bodyPr>
+          <a:lstStyle/>
+          <a:p>
+            <a:r>
+              <a:rPr sz="800" b="1" i="1">
+                <a:solidFill>
+                  <a:srgbClr val="1B3A5C"/>
+                </a:solidFill>
+              </a:rPr>
+              <a:t>SCREENING</a:t>
+            </a:r>
+          </a:p>
+        </p:txBody>
+      </p:sp>
+      <p:sp>
+        <p:nvSpPr>
+          <p:cNvPr id="16" name="TextBox 15"/>
+          <p:cNvSpPr txBox="1"/>
+          <p:nvPr/>
+        </p:nvSpPr>
+        <p:spPr>
+          <a:xfrm>
+            <a:off x="274320" y="3657600"/>
+            <a:ext cx="1645920" cy="457200"/>
+          </a:xfrm>
+          <a:prstGeom prst="rect">
+            <a:avLst/>
+          </a:prstGeom>
+          <a:noFill/>
+        </p:spPr>
+        <p:txBody>
+          <a:bodyPr wrap="none">
+            <a:spAutoFit/>
+          </a:bodyPr>
+          <a:lstStyle/>
+          <a:p>
+            <a:r>
+              <a:rPr sz="800" b="1" i="1">
+                <a:solidFill>
+                  <a:srgbClr val="1B3A5C"/>
+                </a:solidFill>
+              </a:rPr>
+              <a:t>ELIGIBILITY</a:t>
+            </a:r>
+          </a:p>
+        </p:txBody>
+      </p:sp>
+      <p:sp>
+        <p:nvSpPr>
+          <p:cNvPr id="17" name="TextBox 16"/>
+          <p:cNvSpPr txBox="1"/>
+          <p:nvPr/>
+        </p:nvSpPr>
+        <p:spPr>
+          <a:xfrm>
+            <a:off x="274320" y="4572000"/>
+            <a:ext cx="1645920" cy="457200"/>
+          </a:xfrm>
+          <a:prstGeom prst="rect">
+            <a:avLst/>
+          </a:prstGeom>
+          <a:noFill/>
+        </p:spPr>
+        <p:txBody>
+          <a:bodyPr wrap="none">
+            <a:spAutoFit/>
+          </a:bodyPr>
+          <a:lstStyle/>
+          <a:p>
+            <a:r>
+              <a:rPr sz="800" b="1" i="1">
+                <a:solidFill>
+                  <a:srgbClr val="1B3A5C"/>
+                </a:solidFill>
+              </a:rPr>
+              <a:t>INCLUDED</a:t>
+            </a:r>
+          </a:p>
+        </p:txBody>
+      </p:sp>
+      <p:sp>
+        <p:nvSpPr>
+          <p:cNvPr id="18" name="TextBox 17"/>
+          <p:cNvSpPr txBox="1"/>
+          <p:nvPr/>
+        </p:nvSpPr>
+        <p:spPr>
+          <a:xfrm>
+            <a:off x="457200" y="6217920"/>
+            <a:ext cx="11247120" cy="548640"/>
+          </a:xfrm>
+          <a:prstGeom prst="rect">
+            <a:avLst/>
+          </a:prstGeom>
+          <a:noFill/>
+        </p:spPr>
+        <p:txBody>
           <a:bodyPr wrap="square">
             <a:spAutoFit/>
           </a:bodyPr>
@@ -3166,7 +3940,11 @@
           <a:p>
             <a:pPr algn="ctr"/>
             <a:r>
-              <a:rPr sz="1400" i="1"/>
+              <a:rPr sz="1200" i="1">
+                <a:solidFill>
+                  <a:srgbClr val="424242"/>
+                </a:solidFill>
+              </a:rPr>
               <a:t>Figure 1. PRISMA-ScR flow diagram illustrating the source selection process.</a:t>
             </a:r>
           </a:p>

</xml_diff>

<commit_message>
fix: faithfully reproduce original figure designs in editable PPTXs
- Fig 1: Restored all arrows, exclusion boxes, disease-area boxes at bottom
- Fig 3: Heatmap style with colored cells and color bar legend
- Fig 4: All WADA (8) and clinical (10) events with dashed connector lines
- Fig 5: Editable bar chart (PowerPoint chart object)
- Fig 2: Skipped (user editing their own version)

Co-Authored-By: Tatsuki Onishi <bougtoir@gmail.com>
</commit_message>
<xml_diff>
--- a/wada-tue-scoping-review/manuscripts/individual_figures/Figure_1.pptx
+++ b/wada-tue-scoping-review/manuscripts/individual_figures/Figure_1.pptx
@@ -3096,8 +3096,8 @@
         </p:nvSpPr>
         <p:spPr>
           <a:xfrm>
-            <a:off x="457200" y="182880"/>
-            <a:ext cx="11247120" cy="548640"/>
+            <a:off x="457200" y="137160"/>
+            <a:ext cx="11247120" cy="640080"/>
           </a:xfrm>
           <a:prstGeom prst="rect">
             <a:avLst/>
@@ -3112,7 +3112,7 @@
           <a:p>
             <a:pPr algn="ctr"/>
             <a:r>
-              <a:rPr b="1" sz="2000">
+              <a:rPr b="1" sz="1800">
                 <a:solidFill>
                   <a:srgbClr val="1B3A5C"/>
                 </a:solidFill>
@@ -3124,14 +3124,48 @@
       </p:sp>
       <p:sp>
         <p:nvSpPr>
-          <p:cNvPr id="3" name="Rounded Rectangle 2"/>
+          <p:cNvPr id="3" name="TextBox 2"/>
+          <p:cNvSpPr txBox="1"/>
+          <p:nvPr/>
+        </p:nvSpPr>
+        <p:spPr>
+          <a:xfrm>
+            <a:off x="274320" y="822960"/>
+            <a:ext cx="1828800" cy="274320"/>
+          </a:xfrm>
+          <a:prstGeom prst="rect">
+            <a:avLst/>
+          </a:prstGeom>
+          <a:noFill/>
+        </p:spPr>
+        <p:txBody>
+          <a:bodyPr wrap="square">
+            <a:spAutoFit/>
+          </a:bodyPr>
+          <a:lstStyle/>
+          <a:p>
+            <a:pPr algn="l"/>
+            <a:r>
+              <a:rPr sz="900" b="1" i="1">
+                <a:solidFill>
+                  <a:srgbClr val="1B3A5C"/>
+                </a:solidFill>
+              </a:rPr>
+              <a:t>IDENTIFICATION</a:t>
+            </a:r>
+          </a:p>
+        </p:txBody>
+      </p:sp>
+      <p:sp>
+        <p:nvSpPr>
+          <p:cNvPr id="4" name="Rounded Rectangle 3"/>
           <p:cNvSpPr/>
           <p:nvPr/>
         </p:nvSpPr>
         <p:spPr>
           <a:xfrm>
-            <a:off x="2286000" y="914400"/>
-            <a:ext cx="2743200" cy="640080"/>
+            <a:off x="2743200" y="1005840"/>
+            <a:ext cx="2560320" cy="594360"/>
           </a:xfrm>
           <a:prstGeom prst="roundRect">
             <a:avLst/>
@@ -3160,39 +3194,32 @@
           </a:fontRef>
         </p:style>
         <p:txBody>
-          <a:bodyPr rtlCol="0" anchor="ctr" wrap="square" tIns="50800" bIns="50800"/>
-          <a:lstStyle/>
-          <a:p>
-            <a:pPr algn="ctr">
-              <a:spcBef>
-                <a:spcPts val="0"/>
-              </a:spcBef>
-              <a:spcAft>
-                <a:spcPts val="0"/>
-              </a:spcAft>
-            </a:pPr>
+          <a:bodyPr rtlCol="0" anchor="ctr" wrap="square" tIns="38100" bIns="38100" lIns="50800" rIns="50800"/>
+          <a:lstStyle/>
+          <a:p>
+            <a:pPr algn="ctr"/>
             <a:r>
               <a:rPr sz="900" b="0">
                 <a:solidFill>
                   <a:srgbClr val="424242"/>
                 </a:solidFill>
               </a:rPr>
-              <a:t>Records from database searching
-(n = 847)</a:t>
-            </a:r>
-          </a:p>
-        </p:txBody>
-      </p:sp>
-      <p:sp>
-        <p:nvSpPr>
-          <p:cNvPr id="4" name="Rounded Rectangle 3"/>
+              <a:t>Records identified through
+database searching (n = 847)</a:t>
+            </a:r>
+          </a:p>
+        </p:txBody>
+      </p:sp>
+      <p:sp>
+        <p:nvSpPr>
+          <p:cNvPr id="5" name="Rounded Rectangle 4"/>
           <p:cNvSpPr/>
           <p:nvPr/>
         </p:nvSpPr>
         <p:spPr>
           <a:xfrm>
-            <a:off x="6858000" y="914400"/>
-            <a:ext cx="2743200" cy="640080"/>
+            <a:off x="6858000" y="1005840"/>
+            <a:ext cx="2560320" cy="594360"/>
           </a:xfrm>
           <a:prstGeom prst="roundRect">
             <a:avLst/>
@@ -3221,39 +3248,138 @@
           </a:fontRef>
         </p:style>
         <p:txBody>
-          <a:bodyPr rtlCol="0" anchor="ctr" wrap="square" tIns="50800" bIns="50800"/>
-          <a:lstStyle/>
-          <a:p>
-            <a:pPr algn="ctr">
-              <a:spcBef>
-                <a:spcPts val="0"/>
-              </a:spcBef>
-              <a:spcAft>
-                <a:spcPts val="0"/>
-              </a:spcAft>
-            </a:pPr>
+          <a:bodyPr rtlCol="0" anchor="ctr" wrap="square" tIns="38100" bIns="38100" lIns="50800" rIns="50800"/>
+          <a:lstStyle/>
+          <a:p>
+            <a:pPr algn="ctr"/>
             <a:r>
               <a:rPr sz="900" b="0">
                 <a:solidFill>
                   <a:srgbClr val="424242"/>
                 </a:solidFill>
               </a:rPr>
-              <a:t>Additional records from
-grey literature &amp; guidelines (n = 156)</a:t>
-            </a:r>
-          </a:p>
-        </p:txBody>
-      </p:sp>
-      <p:sp>
-        <p:nvSpPr>
-          <p:cNvPr id="5" name="Rounded Rectangle 4"/>
+              <a:t>Additional records from grey
+literature &amp; guidelines (n = 156)</a:t>
+            </a:r>
+          </a:p>
+        </p:txBody>
+      </p:sp>
+      <p:cxnSp>
+        <p:nvCxnSpPr>
+          <p:cNvPr id="6" name="Connector 5"/>
+          <p:cNvCxnSpPr/>
+          <p:nvPr/>
+        </p:nvCxnSpPr>
+        <p:spPr>
+          <a:xfrm>
+            <a:off x="4023360" y="1600200"/>
+            <a:ext cx="1097280" cy="274319"/>
+          </a:xfrm>
+          <a:prstGeom prst="line">
+            <a:avLst/>
+          </a:prstGeom>
+          <a:ln w="19050">
+            <a:solidFill>
+              <a:srgbClr val="424242"/>
+            </a:solidFill>
+            <a:tailEnd type="triangle" w="med" len="med"/>
+          </a:ln>
+        </p:spPr>
+        <p:style>
+          <a:lnRef idx="2">
+            <a:schemeClr val="accent1"/>
+          </a:lnRef>
+          <a:fillRef idx="0">
+            <a:schemeClr val="accent1"/>
+          </a:fillRef>
+          <a:effectRef idx="1">
+            <a:schemeClr val="accent1"/>
+          </a:effectRef>
+          <a:fontRef idx="minor">
+            <a:schemeClr val="tx1"/>
+          </a:fontRef>
+        </p:style>
+      </p:cxnSp>
+      <p:cxnSp>
+        <p:nvCxnSpPr>
+          <p:cNvPr id="7" name="Connector 6"/>
+          <p:cNvCxnSpPr/>
+          <p:nvPr/>
+        </p:nvCxnSpPr>
+        <p:spPr>
+          <a:xfrm flipH="1">
+            <a:off x="7040880" y="1600200"/>
+            <a:ext cx="1097280" cy="274319"/>
+          </a:xfrm>
+          <a:prstGeom prst="line">
+            <a:avLst/>
+          </a:prstGeom>
+          <a:ln w="19050">
+            <a:solidFill>
+              <a:srgbClr val="424242"/>
+            </a:solidFill>
+            <a:tailEnd type="triangle" w="med" len="med"/>
+          </a:ln>
+        </p:spPr>
+        <p:style>
+          <a:lnRef idx="2">
+            <a:schemeClr val="accent1"/>
+          </a:lnRef>
+          <a:fillRef idx="0">
+            <a:schemeClr val="accent1"/>
+          </a:fillRef>
+          <a:effectRef idx="1">
+            <a:schemeClr val="accent1"/>
+          </a:effectRef>
+          <a:fontRef idx="minor">
+            <a:schemeClr val="tx1"/>
+          </a:fontRef>
+        </p:style>
+      </p:cxnSp>
+      <p:sp>
+        <p:nvSpPr>
+          <p:cNvPr id="8" name="TextBox 7"/>
+          <p:cNvSpPr txBox="1"/>
+          <p:nvPr/>
+        </p:nvSpPr>
+        <p:spPr>
+          <a:xfrm>
+            <a:off x="274320" y="1828800"/>
+            <a:ext cx="1828800" cy="274320"/>
+          </a:xfrm>
+          <a:prstGeom prst="rect">
+            <a:avLst/>
+          </a:prstGeom>
+          <a:noFill/>
+        </p:spPr>
+        <p:txBody>
+          <a:bodyPr wrap="square">
+            <a:spAutoFit/>
+          </a:bodyPr>
+          <a:lstStyle/>
+          <a:p>
+            <a:pPr algn="l"/>
+            <a:r>
+              <a:rPr sz="900" b="1" i="1">
+                <a:solidFill>
+                  <a:srgbClr val="1B3A5C"/>
+                </a:solidFill>
+              </a:rPr>
+              <a:t>SCREENING</a:t>
+            </a:r>
+          </a:p>
+        </p:txBody>
+      </p:sp>
+      <p:sp>
+        <p:nvSpPr>
+          <p:cNvPr id="9" name="Rounded Rectangle 8"/>
           <p:cNvSpPr/>
           <p:nvPr/>
         </p:nvSpPr>
         <p:spPr>
           <a:xfrm>
-            <a:off x="3840480" y="1828800"/>
-            <a:ext cx="4114800" cy="640080"/>
+            <a:off x="3840480" y="1920240"/>
+            <a:ext cx="4389120" cy="594360"/>
           </a:xfrm>
           <a:prstGeom prst="roundRect">
             <a:avLst/>
@@ -3282,17 +3408,10 @@
           </a:fontRef>
         </p:style>
         <p:txBody>
-          <a:bodyPr rtlCol="0" anchor="ctr" wrap="square" tIns="50800" bIns="50800"/>
-          <a:lstStyle/>
-          <a:p>
-            <a:pPr algn="ctr">
-              <a:spcBef>
-                <a:spcPts val="0"/>
-              </a:spcBef>
-              <a:spcAft>
-                <a:spcPts val="0"/>
-              </a:spcAft>
-            </a:pPr>
+          <a:bodyPr rtlCol="0" anchor="ctr" wrap="square" tIns="38100" bIns="38100" lIns="50800" rIns="50800"/>
+          <a:lstStyle/>
+          <a:p>
+            <a:pPr algn="ctr"/>
             <a:r>
               <a:rPr sz="1000" b="0">
                 <a:solidFill>
@@ -3304,16 +3423,52 @@
           </a:p>
         </p:txBody>
       </p:sp>
-      <p:sp>
-        <p:nvSpPr>
-          <p:cNvPr id="6" name="Rounded Rectangle 5"/>
+      <p:cxnSp>
+        <p:nvCxnSpPr>
+          <p:cNvPr id="10" name="Connector 9"/>
+          <p:cNvCxnSpPr/>
+          <p:nvPr/>
+        </p:nvCxnSpPr>
+        <p:spPr>
+          <a:xfrm>
+            <a:off x="6035040" y="2514600"/>
+            <a:ext cx="0" cy="274320"/>
+          </a:xfrm>
+          <a:prstGeom prst="line">
+            <a:avLst/>
+          </a:prstGeom>
+          <a:ln w="19050">
+            <a:solidFill>
+              <a:srgbClr val="424242"/>
+            </a:solidFill>
+            <a:tailEnd type="triangle" w="med" len="med"/>
+          </a:ln>
+        </p:spPr>
+        <p:style>
+          <a:lnRef idx="2">
+            <a:schemeClr val="accent1"/>
+          </a:lnRef>
+          <a:fillRef idx="0">
+            <a:schemeClr val="accent1"/>
+          </a:fillRef>
+          <a:effectRef idx="1">
+            <a:schemeClr val="accent1"/>
+          </a:effectRef>
+          <a:fontRef idx="minor">
+            <a:schemeClr val="tx1"/>
+          </a:fontRef>
+        </p:style>
+      </p:cxnSp>
+      <p:sp>
+        <p:nvSpPr>
+          <p:cNvPr id="11" name="Rounded Rectangle 10"/>
           <p:cNvSpPr/>
           <p:nvPr/>
         </p:nvSpPr>
         <p:spPr>
           <a:xfrm>
-            <a:off x="3840480" y="2743200"/>
-            <a:ext cx="4114800" cy="640080"/>
+            <a:off x="3840480" y="2834640"/>
+            <a:ext cx="4389120" cy="594360"/>
           </a:xfrm>
           <a:prstGeom prst="roundRect">
             <a:avLst/>
@@ -3342,17 +3497,10 @@
           </a:fontRef>
         </p:style>
         <p:txBody>
-          <a:bodyPr rtlCol="0" anchor="ctr" wrap="square" tIns="50800" bIns="50800"/>
-          <a:lstStyle/>
-          <a:p>
-            <a:pPr algn="ctr">
-              <a:spcBef>
-                <a:spcPts val="0"/>
-              </a:spcBef>
-              <a:spcAft>
-                <a:spcPts val="0"/>
-              </a:spcAft>
-            </a:pPr>
+          <a:bodyPr rtlCol="0" anchor="ctr" wrap="square" tIns="38100" bIns="38100" lIns="50800" rIns="50800"/>
+          <a:lstStyle/>
+          <a:p>
+            <a:pPr algn="ctr"/>
             <a:r>
               <a:rPr sz="1000" b="0">
                 <a:solidFill>
@@ -3366,14 +3514,14 @@
       </p:sp>
       <p:sp>
         <p:nvSpPr>
-          <p:cNvPr id="7" name="Rounded Rectangle 6"/>
+          <p:cNvPr id="12" name="Rounded Rectangle 11"/>
           <p:cNvSpPr/>
           <p:nvPr/>
         </p:nvSpPr>
         <p:spPr>
           <a:xfrm>
-            <a:off x="8686800" y="2743200"/>
-            <a:ext cx="2286000" cy="640080"/>
+            <a:off x="8686800" y="2834640"/>
+            <a:ext cx="2103120" cy="594360"/>
           </a:xfrm>
           <a:prstGeom prst="roundRect">
             <a:avLst/>
@@ -3402,38 +3550,138 @@
           </a:fontRef>
         </p:style>
         <p:txBody>
-          <a:bodyPr rtlCol="0" anchor="ctr" wrap="square" tIns="50800" bIns="50800"/>
-          <a:lstStyle/>
-          <a:p>
-            <a:pPr algn="ctr">
-              <a:spcBef>
-                <a:spcPts val="0"/>
-              </a:spcBef>
-              <a:spcAft>
-                <a:spcPts val="0"/>
-              </a:spcAft>
-            </a:pPr>
+          <a:bodyPr rtlCol="0" anchor="ctr" wrap="square" tIns="38100" bIns="38100" lIns="50800" rIns="50800"/>
+          <a:lstStyle/>
+          <a:p>
+            <a:pPr algn="ctr"/>
             <a:r>
               <a:rPr sz="900" b="0">
                 <a:solidFill>
                   <a:srgbClr val="424242"/>
                 </a:solidFill>
               </a:rPr>
-              <a:t>Records excluded (n = 518)</a:t>
-            </a:r>
-          </a:p>
-        </p:txBody>
-      </p:sp>
-      <p:sp>
-        <p:nvSpPr>
-          <p:cNvPr id="8" name="Rounded Rectangle 7"/>
+              <a:t>Records excluded
+(n = 518)</a:t>
+            </a:r>
+          </a:p>
+        </p:txBody>
+      </p:sp>
+      <p:cxnSp>
+        <p:nvCxnSpPr>
+          <p:cNvPr id="13" name="Connector 12"/>
+          <p:cNvCxnSpPr/>
+          <p:nvPr/>
+        </p:nvCxnSpPr>
+        <p:spPr>
+          <a:xfrm>
+            <a:off x="8229600" y="3108960"/>
+            <a:ext cx="457200" cy="0"/>
+          </a:xfrm>
+          <a:prstGeom prst="line">
+            <a:avLst/>
+          </a:prstGeom>
+          <a:ln w="19050">
+            <a:solidFill>
+              <a:srgbClr val="424242"/>
+            </a:solidFill>
+            <a:tailEnd type="triangle" w="med" len="med"/>
+          </a:ln>
+        </p:spPr>
+        <p:style>
+          <a:lnRef idx="2">
+            <a:schemeClr val="accent1"/>
+          </a:lnRef>
+          <a:fillRef idx="0">
+            <a:schemeClr val="accent1"/>
+          </a:fillRef>
+          <a:effectRef idx="1">
+            <a:schemeClr val="accent1"/>
+          </a:effectRef>
+          <a:fontRef idx="minor">
+            <a:schemeClr val="tx1"/>
+          </a:fontRef>
+        </p:style>
+      </p:cxnSp>
+      <p:cxnSp>
+        <p:nvCxnSpPr>
+          <p:cNvPr id="14" name="Connector 13"/>
+          <p:cNvCxnSpPr/>
+          <p:nvPr/>
+        </p:nvCxnSpPr>
+        <p:spPr>
+          <a:xfrm>
+            <a:off x="6035040" y="3429000"/>
+            <a:ext cx="0" cy="274320"/>
+          </a:xfrm>
+          <a:prstGeom prst="line">
+            <a:avLst/>
+          </a:prstGeom>
+          <a:ln w="19050">
+            <a:solidFill>
+              <a:srgbClr val="424242"/>
+            </a:solidFill>
+            <a:tailEnd type="triangle" w="med" len="med"/>
+          </a:ln>
+        </p:spPr>
+        <p:style>
+          <a:lnRef idx="2">
+            <a:schemeClr val="accent1"/>
+          </a:lnRef>
+          <a:fillRef idx="0">
+            <a:schemeClr val="accent1"/>
+          </a:fillRef>
+          <a:effectRef idx="1">
+            <a:schemeClr val="accent1"/>
+          </a:effectRef>
+          <a:fontRef idx="minor">
+            <a:schemeClr val="tx1"/>
+          </a:fontRef>
+        </p:style>
+      </p:cxnSp>
+      <p:sp>
+        <p:nvSpPr>
+          <p:cNvPr id="15" name="TextBox 14"/>
+          <p:cNvSpPr txBox="1"/>
+          <p:nvPr/>
+        </p:nvSpPr>
+        <p:spPr>
+          <a:xfrm>
+            <a:off x="274320" y="3657600"/>
+            <a:ext cx="1828800" cy="274320"/>
+          </a:xfrm>
+          <a:prstGeom prst="rect">
+            <a:avLst/>
+          </a:prstGeom>
+          <a:noFill/>
+        </p:spPr>
+        <p:txBody>
+          <a:bodyPr wrap="square">
+            <a:spAutoFit/>
+          </a:bodyPr>
+          <a:lstStyle/>
+          <a:p>
+            <a:pPr algn="l"/>
+            <a:r>
+              <a:rPr sz="900" b="1" i="1">
+                <a:solidFill>
+                  <a:srgbClr val="1B3A5C"/>
+                </a:solidFill>
+              </a:rPr>
+              <a:t>ELIGIBILITY</a:t>
+            </a:r>
+          </a:p>
+        </p:txBody>
+      </p:sp>
+      <p:sp>
+        <p:nvSpPr>
+          <p:cNvPr id="16" name="Rounded Rectangle 15"/>
           <p:cNvSpPr/>
           <p:nvPr/>
         </p:nvSpPr>
         <p:spPr>
           <a:xfrm>
-            <a:off x="3840480" y="3657600"/>
-            <a:ext cx="4114800" cy="640080"/>
+            <a:off x="3840480" y="3749039"/>
+            <a:ext cx="4389120" cy="594360"/>
           </a:xfrm>
           <a:prstGeom prst="roundRect">
             <a:avLst/>
@@ -3462,38 +3710,31 @@
           </a:fontRef>
         </p:style>
         <p:txBody>
-          <a:bodyPr rtlCol="0" anchor="ctr" wrap="square" tIns="50800" bIns="50800"/>
-          <a:lstStyle/>
-          <a:p>
-            <a:pPr algn="ctr">
-              <a:spcBef>
-                <a:spcPts val="0"/>
-              </a:spcBef>
-              <a:spcAft>
-                <a:spcPts val="0"/>
-              </a:spcAft>
-            </a:pPr>
+          <a:bodyPr rtlCol="0" anchor="ctr" wrap="square" tIns="38100" bIns="38100" lIns="50800" rIns="50800"/>
+          <a:lstStyle/>
+          <a:p>
+            <a:pPr algn="ctr"/>
             <a:r>
               <a:rPr sz="1000" b="0">
                 <a:solidFill>
                   <a:srgbClr val="424242"/>
                 </a:solidFill>
               </a:rPr>
-              <a:t>Full-text assessed for eligibility (n = 206)</a:t>
-            </a:r>
-          </a:p>
-        </p:txBody>
-      </p:sp>
-      <p:sp>
-        <p:nvSpPr>
-          <p:cNvPr id="9" name="Rounded Rectangle 8"/>
+              <a:t>Full-text articles assessed for eligibility (n = 206)</a:t>
+            </a:r>
+          </a:p>
+        </p:txBody>
+      </p:sp>
+      <p:sp>
+        <p:nvSpPr>
+          <p:cNvPr id="17" name="Rounded Rectangle 16"/>
           <p:cNvSpPr/>
           <p:nvPr/>
         </p:nvSpPr>
         <p:spPr>
           <a:xfrm>
-            <a:off x="8686800" y="3657600"/>
-            <a:ext cx="2286000" cy="640080"/>
+            <a:off x="8686800" y="3749039"/>
+            <a:ext cx="2103120" cy="594360"/>
           </a:xfrm>
           <a:prstGeom prst="roundRect">
             <a:avLst/>
@@ -3522,38 +3763,195 @@
           </a:fontRef>
         </p:style>
         <p:txBody>
-          <a:bodyPr rtlCol="0" anchor="ctr" wrap="square" tIns="50800" bIns="50800"/>
-          <a:lstStyle/>
-          <a:p>
-            <a:pPr algn="ctr">
-              <a:spcBef>
-                <a:spcPts val="0"/>
-              </a:spcBef>
-              <a:spcAft>
-                <a:spcPts val="0"/>
-              </a:spcAft>
-            </a:pPr>
+          <a:bodyPr rtlCol="0" anchor="ctr" wrap="square" tIns="38100" bIns="38100" lIns="50800" rIns="50800"/>
+          <a:lstStyle/>
+          <a:p>
+            <a:pPr algn="ctr"/>
             <a:r>
               <a:rPr sz="900" b="0">
                 <a:solidFill>
                   <a:srgbClr val="424242"/>
                 </a:solidFill>
               </a:rPr>
-              <a:t>Full-text excluded (n = 138)</a:t>
-            </a:r>
-          </a:p>
-        </p:txBody>
-      </p:sp>
-      <p:sp>
-        <p:nvSpPr>
-          <p:cNvPr id="10" name="Rounded Rectangle 9"/>
+              <a:t>Full-text excluded
+(n = 138)</a:t>
+            </a:r>
+          </a:p>
+        </p:txBody>
+      </p:sp>
+      <p:cxnSp>
+        <p:nvCxnSpPr>
+          <p:cNvPr id="18" name="Connector 17"/>
+          <p:cNvCxnSpPr/>
+          <p:nvPr/>
+        </p:nvCxnSpPr>
+        <p:spPr>
+          <a:xfrm>
+            <a:off x="8229600" y="4023360"/>
+            <a:ext cx="457200" cy="0"/>
+          </a:xfrm>
+          <a:prstGeom prst="line">
+            <a:avLst/>
+          </a:prstGeom>
+          <a:ln w="19050">
+            <a:solidFill>
+              <a:srgbClr val="424242"/>
+            </a:solidFill>
+            <a:tailEnd type="triangle" w="med" len="med"/>
+          </a:ln>
+        </p:spPr>
+        <p:style>
+          <a:lnRef idx="2">
+            <a:schemeClr val="accent1"/>
+          </a:lnRef>
+          <a:fillRef idx="0">
+            <a:schemeClr val="accent1"/>
+          </a:fillRef>
+          <a:effectRef idx="1">
+            <a:schemeClr val="accent1"/>
+          </a:effectRef>
+          <a:fontRef idx="minor">
+            <a:schemeClr val="tx1"/>
+          </a:fontRef>
+        </p:style>
+      </p:cxnSp>
+      <p:sp>
+        <p:nvSpPr>
+          <p:cNvPr id="19" name="Rounded Rectangle 18"/>
           <p:cNvSpPr/>
           <p:nvPr/>
         </p:nvSpPr>
         <p:spPr>
           <a:xfrm>
-            <a:off x="3840480" y="4572000"/>
-            <a:ext cx="4114800" cy="640080"/>
+            <a:off x="8503920" y="4389120"/>
+            <a:ext cx="2926080" cy="914400"/>
+          </a:xfrm>
+          <a:prstGeom prst="roundRect">
+            <a:avLst/>
+          </a:prstGeom>
+          <a:solidFill>
+            <a:srgbClr val="FFF9C4"/>
+          </a:solidFill>
+          <a:ln w="19050">
+            <a:solidFill>
+              <a:srgbClr val="BDBDBD"/>
+            </a:solidFill>
+          </a:ln>
+        </p:spPr>
+        <p:style>
+          <a:lnRef idx="1">
+            <a:schemeClr val="accent1"/>
+          </a:lnRef>
+          <a:fillRef idx="3">
+            <a:schemeClr val="accent1"/>
+          </a:fillRef>
+          <a:effectRef idx="2">
+            <a:schemeClr val="accent1"/>
+          </a:effectRef>
+          <a:fontRef idx="minor">
+            <a:schemeClr val="lt1"/>
+          </a:fontRef>
+        </p:style>
+        <p:txBody>
+          <a:bodyPr rtlCol="0" anchor="ctr" wrap="square" tIns="38100" bIns="38100" lIns="50800" rIns="50800"/>
+          <a:lstStyle/>
+          <a:p>
+            <a:pPr algn="ctr"/>
+            <a:r>
+              <a:rPr sz="700" b="0">
+                <a:solidFill>
+                  <a:srgbClr val="757575"/>
+                </a:solidFill>
+              </a:rPr>
+              <a:t>Reasons for exclusion:
+- Not athlete-specific (n=42)
+- Outdated guidelines (n=31)
+- Not TUE-related (n=38)
+- Duplicate data (n=27)</a:t>
+            </a:r>
+          </a:p>
+        </p:txBody>
+      </p:sp>
+      <p:cxnSp>
+        <p:nvCxnSpPr>
+          <p:cNvPr id="20" name="Connector 19"/>
+          <p:cNvCxnSpPr/>
+          <p:nvPr/>
+        </p:nvCxnSpPr>
+        <p:spPr>
+          <a:xfrm>
+            <a:off x="6035040" y="4343400"/>
+            <a:ext cx="0" cy="274320"/>
+          </a:xfrm>
+          <a:prstGeom prst="line">
+            <a:avLst/>
+          </a:prstGeom>
+          <a:ln w="19050">
+            <a:solidFill>
+              <a:srgbClr val="424242"/>
+            </a:solidFill>
+            <a:tailEnd type="triangle" w="med" len="med"/>
+          </a:ln>
+        </p:spPr>
+        <p:style>
+          <a:lnRef idx="2">
+            <a:schemeClr val="accent1"/>
+          </a:lnRef>
+          <a:fillRef idx="0">
+            <a:schemeClr val="accent1"/>
+          </a:fillRef>
+          <a:effectRef idx="1">
+            <a:schemeClr val="accent1"/>
+          </a:effectRef>
+          <a:fontRef idx="minor">
+            <a:schemeClr val="tx1"/>
+          </a:fontRef>
+        </p:style>
+      </p:cxnSp>
+      <p:sp>
+        <p:nvSpPr>
+          <p:cNvPr id="21" name="TextBox 20"/>
+          <p:cNvSpPr txBox="1"/>
+          <p:nvPr/>
+        </p:nvSpPr>
+        <p:spPr>
+          <a:xfrm>
+            <a:off x="274320" y="4572000"/>
+            <a:ext cx="1828800" cy="274320"/>
+          </a:xfrm>
+          <a:prstGeom prst="rect">
+            <a:avLst/>
+          </a:prstGeom>
+          <a:noFill/>
+        </p:spPr>
+        <p:txBody>
+          <a:bodyPr wrap="square">
+            <a:spAutoFit/>
+          </a:bodyPr>
+          <a:lstStyle/>
+          <a:p>
+            <a:pPr algn="l"/>
+            <a:r>
+              <a:rPr sz="900" b="1" i="1">
+                <a:solidFill>
+                  <a:srgbClr val="1B3A5C"/>
+                </a:solidFill>
+              </a:rPr>
+              <a:t>INCLUDED</a:t>
+            </a:r>
+          </a:p>
+        </p:txBody>
+      </p:sp>
+      <p:sp>
+        <p:nvSpPr>
+          <p:cNvPr id="22" name="Rounded Rectangle 21"/>
+          <p:cNvSpPr/>
+          <p:nvPr/>
+        </p:nvSpPr>
+        <p:spPr>
+          <a:xfrm>
+            <a:off x="3840480" y="4663440"/>
+            <a:ext cx="4389120" cy="594360"/>
           </a:xfrm>
           <a:prstGeom prst="roundRect">
             <a:avLst/>
@@ -3582,38 +3980,139 @@
           </a:fontRef>
         </p:style>
         <p:txBody>
-          <a:bodyPr rtlCol="0" anchor="ctr" wrap="square" tIns="50800" bIns="50800"/>
-          <a:lstStyle/>
-          <a:p>
-            <a:pPr algn="ctr">
-              <a:spcBef>
-                <a:spcPts val="0"/>
-              </a:spcBef>
-              <a:spcAft>
-                <a:spcPts val="0"/>
-              </a:spcAft>
-            </a:pPr>
+          <a:bodyPr rtlCol="0" anchor="ctr" wrap="square" tIns="38100" bIns="38100" lIns="50800" rIns="50800"/>
+          <a:lstStyle/>
+          <a:p>
+            <a:pPr algn="ctr"/>
             <a:r>
               <a:rPr sz="1100" b="1">
                 <a:solidFill>
                   <a:srgbClr val="424242"/>
                 </a:solidFill>
               </a:rPr>
-              <a:t>Sources included in review (n = 68)</a:t>
-            </a:r>
-          </a:p>
-        </p:txBody>
-      </p:sp>
-      <p:sp>
-        <p:nvSpPr>
-          <p:cNvPr id="11" name="Rounded Rectangle 10"/>
+              <a:t>Sources of evidence included in review (n = 68)</a:t>
+            </a:r>
+          </a:p>
+        </p:txBody>
+      </p:sp>
+      <p:cxnSp>
+        <p:nvCxnSpPr>
+          <p:cNvPr id="23" name="Connector 22"/>
+          <p:cNvCxnSpPr/>
+          <p:nvPr/>
+        </p:nvCxnSpPr>
+        <p:spPr>
+          <a:xfrm flipH="1">
+            <a:off x="3200400" y="5257800"/>
+            <a:ext cx="1737360" cy="274320"/>
+          </a:xfrm>
+          <a:prstGeom prst="line">
+            <a:avLst/>
+          </a:prstGeom>
+          <a:ln w="19050">
+            <a:solidFill>
+              <a:srgbClr val="424242"/>
+            </a:solidFill>
+            <a:tailEnd type="triangle" w="med" len="med"/>
+          </a:ln>
+        </p:spPr>
+        <p:style>
+          <a:lnRef idx="2">
+            <a:schemeClr val="accent1"/>
+          </a:lnRef>
+          <a:fillRef idx="0">
+            <a:schemeClr val="accent1"/>
+          </a:fillRef>
+          <a:effectRef idx="1">
+            <a:schemeClr val="accent1"/>
+          </a:effectRef>
+          <a:fontRef idx="minor">
+            <a:schemeClr val="tx1"/>
+          </a:fontRef>
+        </p:style>
+      </p:cxnSp>
+      <p:cxnSp>
+        <p:nvCxnSpPr>
+          <p:cNvPr id="24" name="Connector 23"/>
+          <p:cNvCxnSpPr/>
+          <p:nvPr/>
+        </p:nvCxnSpPr>
+        <p:spPr>
+          <a:xfrm>
+            <a:off x="6035040" y="5257800"/>
+            <a:ext cx="0" cy="274320"/>
+          </a:xfrm>
+          <a:prstGeom prst="line">
+            <a:avLst/>
+          </a:prstGeom>
+          <a:ln w="19050">
+            <a:solidFill>
+              <a:srgbClr val="424242"/>
+            </a:solidFill>
+            <a:tailEnd type="triangle" w="med" len="med"/>
+          </a:ln>
+        </p:spPr>
+        <p:style>
+          <a:lnRef idx="2">
+            <a:schemeClr val="accent1"/>
+          </a:lnRef>
+          <a:fillRef idx="0">
+            <a:schemeClr val="accent1"/>
+          </a:fillRef>
+          <a:effectRef idx="1">
+            <a:schemeClr val="accent1"/>
+          </a:effectRef>
+          <a:fontRef idx="minor">
+            <a:schemeClr val="tx1"/>
+          </a:fontRef>
+        </p:style>
+      </p:cxnSp>
+      <p:cxnSp>
+        <p:nvCxnSpPr>
+          <p:cNvPr id="25" name="Connector 24"/>
+          <p:cNvCxnSpPr/>
+          <p:nvPr/>
+        </p:nvCxnSpPr>
+        <p:spPr>
+          <a:xfrm>
+            <a:off x="7132320" y="5257800"/>
+            <a:ext cx="1737360" cy="274320"/>
+          </a:xfrm>
+          <a:prstGeom prst="line">
+            <a:avLst/>
+          </a:prstGeom>
+          <a:ln w="19050">
+            <a:solidFill>
+              <a:srgbClr val="424242"/>
+            </a:solidFill>
+            <a:tailEnd type="triangle" w="med" len="med"/>
+          </a:ln>
+        </p:spPr>
+        <p:style>
+          <a:lnRef idx="2">
+            <a:schemeClr val="accent1"/>
+          </a:lnRef>
+          <a:fillRef idx="0">
+            <a:schemeClr val="accent1"/>
+          </a:fillRef>
+          <a:effectRef idx="1">
+            <a:schemeClr val="accent1"/>
+          </a:effectRef>
+          <a:fontRef idx="minor">
+            <a:schemeClr val="tx1"/>
+          </a:fontRef>
+        </p:style>
+      </p:cxnSp>
+      <p:sp>
+        <p:nvSpPr>
+          <p:cNvPr id="26" name="Rounded Rectangle 25"/>
           <p:cNvSpPr/>
           <p:nvPr/>
         </p:nvSpPr>
         <p:spPr>
           <a:xfrm>
-            <a:off x="1828800" y="5486400"/>
-            <a:ext cx="2560320" cy="548640"/>
+            <a:off x="2103120" y="5577840"/>
+            <a:ext cx="2286000" cy="502920"/>
           </a:xfrm>
           <a:prstGeom prst="roundRect">
             <a:avLst/>
@@ -3642,38 +4141,32 @@
           </a:fontRef>
         </p:style>
         <p:txBody>
-          <a:bodyPr rtlCol="0" anchor="ctr" wrap="square" tIns="50800" bIns="50800"/>
-          <a:lstStyle/>
-          <a:p>
-            <a:pPr algn="ctr">
-              <a:spcBef>
-                <a:spcPts val="0"/>
-              </a:spcBef>
-              <a:spcAft>
-                <a:spcPts val="0"/>
-              </a:spcAft>
-            </a:pPr>
-            <a:r>
-              <a:rPr sz="900" b="0">
+          <a:bodyPr rtlCol="0" anchor="ctr" wrap="square" tIns="38100" bIns="38100" lIns="50800" rIns="50800"/>
+          <a:lstStyle/>
+          <a:p>
+            <a:pPr algn="ctr"/>
+            <a:r>
+              <a:rPr sz="800" b="0">
                 <a:solidFill>
                   <a:srgbClr val="424242"/>
                 </a:solidFill>
               </a:rPr>
-              <a:t>WADA regulatory docs (n = 18)</a:t>
-            </a:r>
-          </a:p>
-        </p:txBody>
-      </p:sp>
-      <p:sp>
-        <p:nvSpPr>
-          <p:cNvPr id="12" name="Rounded Rectangle 11"/>
+              <a:t>WADA regulatory
+documents (n = 18)</a:t>
+            </a:r>
+          </a:p>
+        </p:txBody>
+      </p:sp>
+      <p:sp>
+        <p:nvSpPr>
+          <p:cNvPr id="27" name="Rounded Rectangle 26"/>
           <p:cNvSpPr/>
           <p:nvPr/>
         </p:nvSpPr>
         <p:spPr>
           <a:xfrm>
-            <a:off x="4754880" y="5486400"/>
-            <a:ext cx="2560320" cy="548640"/>
+            <a:off x="4937760" y="5577840"/>
+            <a:ext cx="2286000" cy="502920"/>
           </a:xfrm>
           <a:prstGeom prst="roundRect">
             <a:avLst/>
@@ -3702,38 +4195,32 @@
           </a:fontRef>
         </p:style>
         <p:txBody>
-          <a:bodyPr rtlCol="0" anchor="ctr" wrap="square" tIns="50800" bIns="50800"/>
-          <a:lstStyle/>
-          <a:p>
-            <a:pPr algn="ctr">
-              <a:spcBef>
-                <a:spcPts val="0"/>
-              </a:spcBef>
-              <a:spcAft>
-                <a:spcPts val="0"/>
-              </a:spcAft>
-            </a:pPr>
-            <a:r>
-              <a:rPr sz="900" b="0">
+          <a:bodyPr rtlCol="0" anchor="ctr" wrap="square" tIns="38100" bIns="38100" lIns="50800" rIns="50800"/>
+          <a:lstStyle/>
+          <a:p>
+            <a:pPr algn="ctr"/>
+            <a:r>
+              <a:rPr sz="800" b="0">
                 <a:solidFill>
                   <a:srgbClr val="424242"/>
                 </a:solidFill>
               </a:rPr>
-              <a:t>Clinical practice guidelines (n = 22)</a:t>
-            </a:r>
-          </a:p>
-        </p:txBody>
-      </p:sp>
-      <p:sp>
-        <p:nvSpPr>
-          <p:cNvPr id="13" name="Rounded Rectangle 12"/>
+              <a:t>Clinical practice
+guidelines (n = 22)</a:t>
+            </a:r>
+          </a:p>
+        </p:txBody>
+      </p:sp>
+      <p:sp>
+        <p:nvSpPr>
+          <p:cNvPr id="28" name="Rounded Rectangle 27"/>
           <p:cNvSpPr/>
           <p:nvPr/>
         </p:nvSpPr>
         <p:spPr>
           <a:xfrm>
-            <a:off x="7680960" y="5486400"/>
-            <a:ext cx="2560320" cy="548640"/>
+            <a:off x="7772400" y="5577840"/>
+            <a:ext cx="2286000" cy="502920"/>
           </a:xfrm>
           <a:prstGeom prst="roundRect">
             <a:avLst/>
@@ -3762,38 +4249,32 @@
           </a:fontRef>
         </p:style>
         <p:txBody>
-          <a:bodyPr rtlCol="0" anchor="ctr" wrap="square" tIns="50800" bIns="50800"/>
-          <a:lstStyle/>
-          <a:p>
-            <a:pPr algn="ctr">
-              <a:spcBef>
-                <a:spcPts val="0"/>
-              </a:spcBef>
-              <a:spcAft>
-                <a:spcPts val="0"/>
-              </a:spcAft>
-            </a:pPr>
-            <a:r>
-              <a:rPr sz="900" b="0">
+          <a:bodyPr rtlCol="0" anchor="ctr" wrap="square" tIns="38100" bIns="38100" lIns="50800" rIns="50800"/>
+          <a:lstStyle/>
+          <a:p>
+            <a:pPr algn="ctr"/>
+            <a:r>
+              <a:rPr sz="800" b="0">
                 <a:solidFill>
                   <a:srgbClr val="424242"/>
                 </a:solidFill>
               </a:rPr>
-              <a:t>Peer-reviewed articles (n = 28)</a:t>
-            </a:r>
-          </a:p>
-        </p:txBody>
-      </p:sp>
-      <p:sp>
-        <p:nvSpPr>
-          <p:cNvPr id="14" name="TextBox 13"/>
+              <a:t>Peer-reviewed
+articles (n = 28)</a:t>
+            </a:r>
+          </a:p>
+        </p:txBody>
+      </p:sp>
+      <p:sp>
+        <p:nvSpPr>
+          <p:cNvPr id="29" name="TextBox 28"/>
           <p:cNvSpPr txBox="1"/>
           <p:nvPr/>
         </p:nvSpPr>
         <p:spPr>
           <a:xfrm>
-            <a:off x="274320" y="914400"/>
-            <a:ext cx="1645920" cy="457200"/>
+            <a:off x="3200400" y="6126480"/>
+            <a:ext cx="5486400" cy="274320"/>
           </a:xfrm>
           <a:prstGeom prst="rect">
             <a:avLst/>
@@ -3801,32 +4282,33 @@
           <a:noFill/>
         </p:spPr>
         <p:txBody>
-          <a:bodyPr wrap="none">
+          <a:bodyPr wrap="square">
             <a:spAutoFit/>
           </a:bodyPr>
           <a:lstStyle/>
           <a:p>
-            <a:r>
-              <a:rPr sz="800" b="1" i="1">
+            <a:pPr algn="ctr"/>
+            <a:r>
+              <a:rPr sz="700" b="1" i="0">
                 <a:solidFill>
-                  <a:srgbClr val="1B3A5C"/>
+                  <a:srgbClr val="757575"/>
                 </a:solidFill>
               </a:rPr>
-              <a:t>IDENTIFICATION</a:t>
-            </a:r>
-          </a:p>
-        </p:txBody>
-      </p:sp>
-      <p:sp>
-        <p:nvSpPr>
-          <p:cNvPr id="15" name="TextBox 14"/>
+              <a:t>Disease Areas Mapped: Asthma (n=12) | ADHD (n=9) | Diabetes/GLP-1 (n=11) | Hypogonadism (n=10) | GC (n=9) | CV (n=8) | PCOS (n=9)</a:t>
+            </a:r>
+          </a:p>
+        </p:txBody>
+      </p:sp>
+      <p:sp>
+        <p:nvSpPr>
+          <p:cNvPr id="30" name="TextBox 29"/>
           <p:cNvSpPr txBox="1"/>
           <p:nvPr/>
         </p:nvSpPr>
         <p:spPr>
           <a:xfrm>
-            <a:off x="274320" y="2743200"/>
-            <a:ext cx="1645920" cy="457200"/>
+            <a:off x="457200" y="6400800"/>
+            <a:ext cx="11247120" cy="365760"/>
           </a:xfrm>
           <a:prstGeom prst="rect">
             <a:avLst/>
@@ -3834,105 +4316,6 @@
           <a:noFill/>
         </p:spPr>
         <p:txBody>
-          <a:bodyPr wrap="none">
-            <a:spAutoFit/>
-          </a:bodyPr>
-          <a:lstStyle/>
-          <a:p>
-            <a:r>
-              <a:rPr sz="800" b="1" i="1">
-                <a:solidFill>
-                  <a:srgbClr val="1B3A5C"/>
-                </a:solidFill>
-              </a:rPr>
-              <a:t>SCREENING</a:t>
-            </a:r>
-          </a:p>
-        </p:txBody>
-      </p:sp>
-      <p:sp>
-        <p:nvSpPr>
-          <p:cNvPr id="16" name="TextBox 15"/>
-          <p:cNvSpPr txBox="1"/>
-          <p:nvPr/>
-        </p:nvSpPr>
-        <p:spPr>
-          <a:xfrm>
-            <a:off x="274320" y="3657600"/>
-            <a:ext cx="1645920" cy="457200"/>
-          </a:xfrm>
-          <a:prstGeom prst="rect">
-            <a:avLst/>
-          </a:prstGeom>
-          <a:noFill/>
-        </p:spPr>
-        <p:txBody>
-          <a:bodyPr wrap="none">
-            <a:spAutoFit/>
-          </a:bodyPr>
-          <a:lstStyle/>
-          <a:p>
-            <a:r>
-              <a:rPr sz="800" b="1" i="1">
-                <a:solidFill>
-                  <a:srgbClr val="1B3A5C"/>
-                </a:solidFill>
-              </a:rPr>
-              <a:t>ELIGIBILITY</a:t>
-            </a:r>
-          </a:p>
-        </p:txBody>
-      </p:sp>
-      <p:sp>
-        <p:nvSpPr>
-          <p:cNvPr id="17" name="TextBox 16"/>
-          <p:cNvSpPr txBox="1"/>
-          <p:nvPr/>
-        </p:nvSpPr>
-        <p:spPr>
-          <a:xfrm>
-            <a:off x="274320" y="4572000"/>
-            <a:ext cx="1645920" cy="457200"/>
-          </a:xfrm>
-          <a:prstGeom prst="rect">
-            <a:avLst/>
-          </a:prstGeom>
-          <a:noFill/>
-        </p:spPr>
-        <p:txBody>
-          <a:bodyPr wrap="none">
-            <a:spAutoFit/>
-          </a:bodyPr>
-          <a:lstStyle/>
-          <a:p>
-            <a:r>
-              <a:rPr sz="800" b="1" i="1">
-                <a:solidFill>
-                  <a:srgbClr val="1B3A5C"/>
-                </a:solidFill>
-              </a:rPr>
-              <a:t>INCLUDED</a:t>
-            </a:r>
-          </a:p>
-        </p:txBody>
-      </p:sp>
-      <p:sp>
-        <p:nvSpPr>
-          <p:cNvPr id="18" name="TextBox 17"/>
-          <p:cNvSpPr txBox="1"/>
-          <p:nvPr/>
-        </p:nvSpPr>
-        <p:spPr>
-          <a:xfrm>
-            <a:off x="457200" y="6217920"/>
-            <a:ext cx="11247120" cy="548640"/>
-          </a:xfrm>
-          <a:prstGeom prst="rect">
-            <a:avLst/>
-          </a:prstGeom>
-          <a:noFill/>
-        </p:spPr>
-        <p:txBody>
           <a:bodyPr wrap="square">
             <a:spAutoFit/>
           </a:bodyPr>
@@ -3940,7 +4323,7 @@
           <a:p>
             <a:pPr algn="ctr"/>
             <a:r>
-              <a:rPr sz="1200" i="1">
+              <a:rPr sz="1100" i="1">
                 <a:solidFill>
                   <a:srgbClr val="424242"/>
                 </a:solidFill>

</xml_diff>